<commit_message>
Model usable robot inference access and align PS2 artifacts
</commit_message>
<xml_diff>
--- a/submission/PS2-FP9-ComputeCommons-A0-Poster.pptx
+++ b/submission/PS2-FP9-ComputeCommons-A0-Poster.pptx
@@ -2,13 +2,13 @@
 <file path=ppt/presentation.xml><?xml version="1.0" encoding="utf-8"?>
 <p:presentation xmlns:p="http://schemas.openxmlformats.org/presentationml/2006/main">
   <p:sldMasterIdLst>
-    <p:sldMasterId xmlns:r="http://schemas.openxmlformats.org/officeDocument/2006/relationships" id="2147483648" r:id="R99739f7dc375477c"/>
+    <p:sldMasterId xmlns:r="http://schemas.openxmlformats.org/officeDocument/2006/relationships" id="2147483648" r:id="R49ba58780a3043e5"/>
   </p:sldMasterIdLst>
   <p:notesMasterIdLst>
-    <p:notesMasterId xmlns:r="http://schemas.openxmlformats.org/officeDocument/2006/relationships" r:id="R646c64291fee43bb"/>
+    <p:notesMasterId xmlns:r="http://schemas.openxmlformats.org/officeDocument/2006/relationships" r:id="R289f6a426f444695"/>
   </p:notesMasterIdLst>
   <p:sldIdLst>
-    <p:sldId xmlns:r="http://schemas.openxmlformats.org/officeDocument/2006/relationships" id="256" r:id="Re4fd1df03123433f"/>
+    <p:sldId xmlns:r="http://schemas.openxmlformats.org/officeDocument/2006/relationships" id="256" r:id="R1081243c88a44548"/>
   </p:sldIdLst>
   <p:sldSz cx="42804000" cy="30276000"/>
   <p:notesSz cx="6858000" cy="9144000"/>
@@ -158,9 +158,9 @@
 </file>
 
 <file path=ppt/notesMasters/theme/theme3.xml><?xml version="1.0" encoding="utf-8"?>
-<a:theme xmlns:a="http://schemas.openxmlformats.org/drawingml/2006/main" name="ChatGPT">
+<a:theme xmlns:a="http://schemas.openxmlformats.org/drawingml/2006/main" name="Compute Commons">
   <a:themeElements>
-    <a:clrScheme name="ChatGPT">
+    <a:clrScheme name="Compute Commons">
       <a:dk1>
         <a:srgbClr val="000000"/>
       </a:dk1>
@@ -210,7 +210,7 @@
         <a:cs typeface="Calibri"/>
       </a:minorFont>
     </a:fontScheme>
-    <a:fmtScheme name="ChatGPT">
+    <a:fmtScheme name="Compute Commons">
       <a:fillStyleLst>
         <a:solidFill>
           <a:schemeClr val="phClr"/>
@@ -442,7 +442,7 @@
           <a:lstStyle xmlns:a="http://schemas.openxmlformats.org/drawingml/2006/main"/>
           <a:p xmlns:a="http://schemas.openxmlformats.org/drawingml/2006/main">
             <a:r>
-              <a:t>Sources: Vickrey (1961), DOI 10.1111/j.1540-6261.1961.tb02789.x; Mahajan et al. (2020), https://www.usenix.org/conference/nsdi20/presentation/mahajan; Kim et al. (2024), https://openvla.github.io/. All table outputs are synthetic fresh-run results from code/model.py, version ps2-review-2026-09-27. Designated GitHub: https://github.com/dku-comsci-econ206-Autumn2026/-PS2-FP9-ComputeCommons; Hugging Face: https://huggingface.co/spaces/dku-comsci-econ206-2026/Xinrong_Sun. PS2 upload pending. AI assistance disclosed in the paper. Template dimensions, institutional logo, colors and layout preserved.</a:t>
+              <a:t>Sources checked 2026-10-05: https://arxiv.org/abs/2506.07339 ; https://arxiv.org/abs/2410.05828 ; https://www.usenix.org/conference/nsdi20/presentation/mahajan ; https://timroughgarden.org/f13/l/l3.pdf . Numerical evidence: code/robot_results.json, version ps2-robot-revision-2026-10-05. Course template adapted, retaining original logo and layout. No participant or robot trials.</a:t>
             </a:r>
           </a:p>
         </p:txBody>
@@ -510,7 +510,7 @@
   </p:cSld>
   <p:clrMap bg1="lt1" tx1="dk1" bg2="lt2" tx2="dk2" accent1="accent1" accent2="accent2" accent3="accent3" accent4="accent4" accent5="accent5" accent6="accent6" hlink="hlink" folHlink="folHlink"/>
   <p:sldLayoutIdLst>
-    <p:sldLayoutId xmlns:r="http://schemas.openxmlformats.org/officeDocument/2006/relationships" id="2147483649" r:id="R9c3512a1ad98451b"/>
+    <p:sldLayoutId xmlns:r="http://schemas.openxmlformats.org/officeDocument/2006/relationships" id="2147483649" r:id="Re388c7f0c2bb4e7d"/>
   </p:sldLayoutIdLst>
   <p:txStyles>
     <p:titleStyle>
@@ -793,9 +793,9 @@
 </file>
 
 <file path=ppt/slideMasters/theme/theme2.xml><?xml version="1.0" encoding="utf-8"?>
-<a:theme xmlns:a="http://schemas.openxmlformats.org/drawingml/2006/main" name="ChatGPT">
+<a:theme xmlns:a="http://schemas.openxmlformats.org/drawingml/2006/main" name="Compute Commons">
   <a:themeElements>
-    <a:clrScheme name="ChatGPT">
+    <a:clrScheme name="Compute Commons">
       <a:dk1>
         <a:srgbClr val="000000"/>
       </a:dk1>
@@ -845,7 +845,7 @@
         <a:cs typeface="Calibri"/>
       </a:minorFont>
     </a:fontScheme>
-    <a:fmtScheme name="ChatGPT">
+    <a:fmtScheme name="Compute Commons">
       <a:fillStyleLst>
         <a:solidFill>
           <a:schemeClr val="phClr"/>
@@ -1200,7 +1200,7 @@
                 <a:ea typeface="Calibri"/>
                 <a:cs typeface="Calibri"/>
               </a:rPr>
-              <a:t>REVIEW DRAFT · 27 SEPTEMBER 2026</a:t>
+              <a:t>RESEARCH REVISION · 5 OCTOBER 2026</a:t>
             </a:r>
           </a:p>
         </p:txBody>
@@ -1259,7 +1259,7 @@
                 <a:ea typeface="Calibri"/>
                 <a:cs typeface="Calibri"/>
               </a:rPr>
-              <a:t>Compute Commons: Access Rights</a:t>
+              <a:t>Compute Commons: Usable Access</a:t>
             </a:r>
           </a:p>
           <a:p xmlns:a="http://schemas.openxmlformats.org/drawingml/2006/main">
@@ -1283,7 +1283,7 @@
                 <a:ea typeface="Calibri"/>
                 <a:cs typeface="Calibri"/>
               </a:rPr>
-              <a:t>in Embodied-AI Inference Auctions</a:t>
+              <a:t>to Robot Inference</a:t>
             </a:r>
           </a:p>
         </p:txBody>
@@ -1415,7 +1415,7 @@
           <p:nvPr/>
         </p:nvPicPr>
         <p:blipFill>
-          <a:blip xmlns:r="http://schemas.openxmlformats.org/officeDocument/2006/relationships" xmlns:a="http://schemas.openxmlformats.org/drawingml/2006/main" r:embed="Rb450d9042a344185"/>
+          <a:blip xmlns:r="http://schemas.openxmlformats.org/officeDocument/2006/relationships" xmlns:a="http://schemas.openxmlformats.org/drawingml/2006/main" r:embed="R321f4e205c9a4984"/>
           <a:stretch xmlns:a="http://schemas.openxmlformats.org/drawingml/2006/main"/>
         </p:blipFill>
         <p:spPr>
@@ -1572,7 +1572,7 @@
                 <a:ea typeface="Calibri"/>
                 <a:cs typeface="Calibri"/>
               </a:rPr>
-              <a:t>Access credits can preserve truthful value bidding,</a:t>
+              <a:t>Robot state changes which compute allocations are usable.</a:t>
             </a:r>
           </a:p>
           <a:p xmlns:a="http://schemas.openxmlformats.org/drawingml/2006/main">
@@ -1596,7 +1596,7 @@
                 <a:ea typeface="Calibri"/>
                 <a:cs typeface="Calibri"/>
               </a:rPr>
-              <a:t>but truthful values do not guarantee truthful eligibility.</a:t>
+              <a:t>Physical feasibility also changes the incentive to bid truthfully.</a:t>
             </a:r>
           </a:p>
         </p:txBody>
@@ -1804,7 +1804,7 @@
                 <a:ea typeface="Calibri"/>
                 <a:cs typeface="Calibri"/>
               </a:rPr>
-              <a:t>Can protected access change who receives inference slots while preserving truthful value reports?</a:t>
+              <a:t>Can access policy deliver usable robot inference while preserving truthful value bids?</a:t>
             </a:r>
           </a:p>
           <a:p xmlns:a="http://schemas.openxmlformats.org/drawingml/2006/main">
@@ -1828,7 +1828,7 @@
                 <a:ea typeface="Calibri"/>
                 <a:cs typeface="Calibri"/>
               </a:rPr>
-              <a:t>Vickrey establishes the incentive benchmark [1]. Themis already auctions GPU resources [2]. We test an institutional boundary, not a new auction theorem.</a:t>
+              <a:t>RTC studies delayed actions [1]. Deadline-aware planning already allocates effort [2]. Our comparison connects usable access to payments and entry priority.</a:t>
             </a:r>
           </a:p>
         </p:txBody>
@@ -1946,7 +1946,7 @@
                 <a:ea typeface="Calibri"/>
                 <a:cs typeface="Calibri"/>
               </a:rPr>
-              <a:t>Three firms want at most one window each. Private values: A = 10, B = 9, E = 6.</a:t>
+              <a:t>Four operators: values A = 10, B = 9, D = 8, E = 6. One server, 400 ms, 200 ms per inference. Only E is an eligible entrant.</a:t>
             </a:r>
           </a:p>
           <a:p xmlns:a="http://schemas.openxmlformats.org/drawingml/2006/main">
@@ -1970,31 +1970,7 @@
                 <a:ea typeface="Calibri"/>
                 <a:cs typeface="Calibri"/>
               </a:rPr>
-              <a:t>Two identical windows. E has verified entrant status. Utility = value − payment if selected.</a:t>
-            </a:r>
-          </a:p>
-          <a:p xmlns:a="http://schemas.openxmlformats.org/drawingml/2006/main">
-            <a:pPr algn="l">
-              <a:buNone/>
-              <a:defRPr sz="3300" b="0">
-                <a:solidFill>
-                  <a:srgbClr val="173047"/>
-                </a:solidFill>
-                <a:latin typeface="Calibri"/>
-                <a:ea typeface="Calibri"/>
-                <a:cs typeface="Calibri"/>
-              </a:defRPr>
-            </a:pPr>
-            <a:r>
-              <a:rPr sz="3300" b="0">
-                <a:solidFill>
-                  <a:srgbClr val="173047"/>
-                </a:solidFill>
-                <a:latin typeface="Calibri"/>
-                <a:ea typeface="Calibri"/>
-                <a:cs typeface="Calibri"/>
-              </a:rPr>
-              <a:t>Static, incomplete information. Truthful bids are weakly dominant and form a BNE.</a:t>
+              <a:t>Deadline = min(queue time, pose-validity time) minus network delay. State is public; value is private.</a:t>
             </a:r>
           </a:p>
         </p:txBody>
@@ -2112,7 +2088,7 @@
                 <a:ea typeface="Calibri"/>
                 <a:cs typeface="Calibri"/>
               </a:rPr>
-              <a:t>Game theory: test unilateral bid deviations.</a:t>
+              <a:t>Game theory: truthful values require timely service and critical payments.</a:t>
             </a:r>
           </a:p>
           <a:p xmlns:a="http://schemas.openxmlformats.org/drawingml/2006/main">
@@ -2136,7 +2112,7 @@
                 <a:ea typeface="Calibri"/>
                 <a:cs typeface="Calibri"/>
               </a:rPr>
-              <a:t>Social choice: report firm value, entrant access and worker authority separately.</a:t>
+              <a:t>Social choice: usable entrant access can cost task value.</a:t>
             </a:r>
           </a:p>
           <a:p xmlns:a="http://schemas.openxmlformats.org/drawingml/2006/main">
@@ -2160,7 +2136,7 @@
                 <a:ea typeface="Calibri"/>
                 <a:cs typeface="Calibri"/>
               </a:rPr>
-              <a:t>Mechanism design: set a credit and reservation before bids, then use critical payments.</a:t>
+              <a:t>Mechanism design: optimize credited bids over physically feasible schedules.</a:t>
             </a:r>
           </a:p>
         </p:txBody>
@@ -2278,7 +2254,7 @@
                 <a:ea typeface="Calibri"/>
                 <a:cs typeface="Calibri"/>
               </a:rPr>
-              <a:t>Score = bid + credit for verified E.</a:t>
+              <a:t>Enumerate feasible subsets; dispatch in deadline order. Charge each winner the bid threshold needed to enter a winning set. Losers pay zero.</a:t>
             </a:r>
           </a:p>
           <a:p xmlns:a="http://schemas.openxmlformats.org/drawingml/2006/main">
@@ -2302,31 +2278,7 @@
                 <a:ea typeface="Calibri"/>
                 <a:cs typeface="Calibri"/>
               </a:rPr>
-              <a:t>Allocate the top remaining scores. Winners pay the highest losing score minus their credit, floored at zero. Fixed ties: A, B, E.</a:t>
-            </a:r>
-          </a:p>
-          <a:p xmlns:a="http://schemas.openxmlformats.org/drawingml/2006/main">
-            <a:pPr algn="l">
-              <a:buNone/>
-              <a:defRPr sz="3150" b="0">
-                <a:solidFill>
-                  <a:srgbClr val="173047"/>
-                </a:solidFill>
-                <a:latin typeface="Calibri"/>
-                <a:ea typeface="Calibri"/>
-                <a:cs typeface="Calibri"/>
-              </a:defRPr>
-            </a:pPr>
-            <a:r>
-              <a:rPr sz="3150" b="0">
-                <a:solidFill>
-                  <a:srgbClr val="173047"/>
-                </a:solidFill>
-                <a:latin typeface="Calibri"/>
-                <a:ea typeface="Calibri"/>
-                <a:cs typeface="Calibri"/>
-              </a:rPr>
-              <a:t>One sealed round ends after payment. This is admission, not real-time robot control.</a:t>
+              <a:t>One sealed round ends after execution and settlement. Telemetry and eligibility must be verified.</a:t>
             </a:r>
           </a:p>
         </p:txBody>
@@ -2508,7 +2460,7 @@
                 <a:ea typeface="Calibri"/>
                 <a:cs typeface="Calibri"/>
               </a:rPr>
-              <a:t>Four rules isolate two public choices</a:t>
+              <a:t>Robot-state constraints define usable service</a:t>
             </a:r>
           </a:p>
         </p:txBody>
@@ -2626,7 +2578,7 @@
                 <a:ea typeface="Calibri"/>
                 <a:cs typeface="Calibri"/>
               </a:rPr>
-              <a:t>Figure 1. Same private values and total capacity in every treatment. Worker reservations remove windows from the commercial auction.</a:t>
+              <a:t>Figure 1. A has only 200 ms of queued actions. B has 400 ms of actions, but target motion makes its pose stale after 200 ms. All numbers are synthetic.</a:t>
             </a:r>
           </a:p>
         </p:txBody>
@@ -2718,7 +2670,7 @@
                 <a:ea typeface="Calibri"/>
                 <a:cs typeface="Calibri"/>
               </a:rPr>
-              <a:t>Actual synthetic comparison</a:t>
+              <a:t>Actual synthetic comparison: usable value</a:t>
             </a:r>
           </a:p>
         </p:txBody>
@@ -2836,7 +2788,7 @@
                 <a:ea typeface="Calibri"/>
                 <a:cs typeface="Calibri"/>
               </a:rPr>
-              <a:t>Credit alone changes winners from A, B to A, E. Firm value falls by 3 while revenue rises by 2.</a:t>
+              <a:t>Generic admission gives B an expired result and utility −8. B can gain by bidding zero.</a:t>
             </a:r>
           </a:p>
           <a:p xmlns:a="http://schemas.openxmlformats.org/drawingml/2006/main">
@@ -2860,7 +2812,7 @@
                 <a:ea typeface="Calibri"/>
                 <a:cs typeface="Calibri"/>
               </a:rPr>
-              <a:t>The combined rule reserves one worker window and admits E. These outputs do not measure human welfare.</a:t>
+              <a:t>Feasible admission restores the stated incentive domain. Credit 3 exchanges 2 value units for usable access by E.</a:t>
             </a:r>
           </a:p>
           <a:p xmlns:a="http://schemas.openxmlformats.org/drawingml/2006/main">
@@ -2884,7 +2836,7 @@
                 <a:ea typeface="Calibri"/>
                 <a:cs typeface="Calibri"/>
               </a:rPr>
-              <a:t>144,439 Python checks pass. Run code/model.py.</a:t>
+              <a:t>36,289 checks; 300 paired synthetic batches. Run code/robot_model.py.</a:t>
             </a:r>
           </a:p>
         </p:txBody>
@@ -3033,7 +2985,7 @@
                 <a:ea typeface="Calibri"/>
                 <a:cs typeface="Calibri"/>
               </a:rPr>
-              <a:t>Proposed case: an OpenVLA testbed</a:t>
+              <a:t>Proposed case: shared manipulation inference</a:t>
             </a:r>
           </a:p>
         </p:txBody>
@@ -3092,7 +3044,7 @@
                 <a:ea typeface="Calibri"/>
                 <a:cs typeface="Calibri"/>
               </a:rPr>
-              <a:t>A shared tabletop-robot evaluation service [3] could admit smaller embodied-AI firms and protect worker-selected task tests.</a:t>
+              <a:t>Small integrators and incumbent operators share a tabletop pick-and-place inference service.</a:t>
             </a:r>
           </a:p>
           <a:p xmlns:a="http://schemas.openxmlformats.org/drawingml/2006/main">
@@ -3116,7 +3068,7 @@
                 <a:ea typeface="Calibri"/>
                 <a:cs typeface="Calibri"/>
               </a:rPr>
-              <a:t>First measure latency, compatibility and actual use of reserved windows. Publish decisions and allow eligibility appeals. No deployment or partnership is claimed.</a:t>
+              <a:t>Measure queue depth, object motion, latency and accepted actions. Workers control reserved evaluation time. Operators can appeal state or eligibility errors. Local controllers handle protective stopping.</a:t>
             </a:r>
           </a:p>
         </p:txBody>
@@ -3234,7 +3186,7 @@
                 <a:ea typeface="Calibri"/>
                 <a:cs typeface="Calibri"/>
               </a:rPr>
-              <a:t>Behavioral artifact: predict a payment, submit a bid, inspect utility and record reflection. Report bid error and utility regret separately.</a:t>
+              <a:t>Behavior: predict a payment and timely completion before seeing the result; export reflection and regret. No human findings are claimed.</a:t>
             </a:r>
           </a:p>
           <a:p xmlns:a="http://schemas.openxmlformats.org/drawingml/2006/main">
@@ -3258,7 +3210,7 @@
                 <a:ea typeface="Calibri"/>
                 <a:cs typeface="Calibri"/>
               </a:rPr>
-              <a:t>Sun’s classroom statement motivates confusion and winning-preference hypotheses. No observed bidding dataset is supplied.</a:t>
+              <a:t>Computation: exact feasible allocation, EDF baseline, state ablations and network-delay stress.</a:t>
             </a:r>
           </a:p>
           <a:p xmlns:a="http://schemas.openxmlformats.org/drawingml/2006/main">
@@ -3282,30 +3234,7 @@
                 <a:ea typeface="Calibri"/>
                 <a:cs typeface="Calibri"/>
               </a:rPr>
-              <a:t>Computational artifact: exact threshold rules, four treatments and a 39-setting sensitivity sweep.</a:t>
-            </a:r>
-          </a:p>
-          <a:p xmlns:a="http://schemas.openxmlformats.org/drawingml/2006/main">
-            <a:pPr>
-              <a:defRPr sz="3225" b="0">
-                <a:solidFill>
-                  <a:srgbClr val="173047"/>
-                </a:solidFill>
-                <a:latin typeface="Calibri"/>
-                <a:ea typeface="Calibri"/>
-                <a:cs typeface="Calibri"/>
-              </a:defRPr>
-            </a:pPr>
-            <a:r>
-              <a:rPr sz="3225" b="0">
-                <a:solidFill>
-                  <a:srgbClr val="173047"/>
-                </a:solidFill>
-                <a:latin typeface="Calibri"/>
-                <a:ea typeface="Calibri"/>
-                <a:cs typeface="Calibri"/>
-              </a:rPr>
-              <a:t>The false-label test changes the design: verify eligibility before bidding.</a:t>
+              <a:t>In 300 synthetic batches, mean usable value is 43.06 for feasible allocation and 38.86 for EDF. These are model outcomes, not robot measurements.</a:t>
             </a:r>
           </a:p>
         </p:txBody>
@@ -3423,7 +3352,7 @@
                 <a:ea typeface="Calibri"/>
                 <a:cs typeface="Calibri"/>
               </a:rPr>
-              <a:t>With reserve 1 and credit 5, A gains 4 by falsely claiming entrant status. A value-truthful mechanism cannot fix this.</a:t>
+              <a:t>No robot trials, learned policy, safety proof or dynamic equilibrium. Exact enumeration is an offline oracle.</a:t>
             </a:r>
           </a:p>
           <a:p xmlns:a="http://schemas.openxmlformats.org/drawingml/2006/main">
@@ -3447,7 +3376,7 @@
                 <a:ea typeface="Calibri"/>
                 <a:cs typeface="Calibri"/>
               </a:rPr>
-              <a:t>Next: verified eligibility, measured inference windows and a comprehension pilot. How should access claims be audited?</a:t>
+              <a:t>Next: calibrated traces, solver-overhead measurement, controlled robot trials and a comprehension pilot.</a:t>
             </a:r>
           </a:p>
         </p:txBody>
@@ -3506,7 +3435,7 @@
                 <a:ea typeface="Calibri"/>
                 <a:cs typeface="Calibri"/>
               </a:rPr>
-              <a:t>SEP 28  Poster discussion and peer challenge</a:t>
+              <a:t>Reserve 100 ms: commercial value 10.</a:t>
             </a:r>
           </a:p>
           <a:p xmlns:a="http://schemas.openxmlformats.org/drawingml/2006/main">
@@ -3530,7 +3459,7 @@
                 <a:ea typeface="Calibri"/>
                 <a:cs typeface="Calibri"/>
               </a:rPr>
-              <a:t>SEP 30  Revision after actual feedback</a:t>
+              <a:t>Reserve + credit 5: E wins, value 6.</a:t>
             </a:r>
           </a:p>
         </p:txBody>
@@ -3679,7 +3608,7 @@
                 <a:ea typeface="Calibri"/>
                 <a:cs typeface="Calibri"/>
               </a:rPr>
-              <a:t>Professor Luyao Zhang: course framing and templates. Sun’s PS1 and classroom account: research direction. Python and browser software: implementation. ChatGPT/Codex: disclosed assistance.</a:t>
+              <a:t>Xinrong Sun developed the original project and identified the revision need. Thanks to Professor Luyao Zhang for feedback and templates. Codex assisted revision; disclosure is in the paper.</a:t>
             </a:r>
           </a:p>
         </p:txBody>
@@ -3797,7 +3726,7 @@
                 <a:ea typeface="Calibri"/>
                 <a:cs typeface="Calibri"/>
               </a:rPr>
-              <a:t>[1] Vickrey (1961). Counterspeculation, Auctions, and Competitive Sealed Tenders. J. Finance 16(1), 8–37. doi:10.1111/j.1540-6261.1961.tb02789.x</a:t>
+              <a:t>[1] Black et al. (2025). Real-Time Execution of Action Chunking Flow Policies. arXiv:2506.07339</a:t>
             </a:r>
           </a:p>
           <a:p xmlns:a="http://schemas.openxmlformats.org/drawingml/2006/main">
@@ -3821,7 +3750,7 @@
                 <a:ea typeface="Calibri"/>
                 <a:cs typeface="Calibri"/>
               </a:rPr>
-              <a:t>[2] Mahajan et al. (2020). Themis: Fair and Efficient GPU Cluster Scheduling. NSDI, 289–304. usenix.org/conference/nsdi20/presentation/mahajan</a:t>
+              <a:t>[2] Sung et al. (2024). Deadline-Aware Task and Motion Planning. arXiv:2410.05828</a:t>
             </a:r>
           </a:p>
           <a:p xmlns:a="http://schemas.openxmlformats.org/drawingml/2006/main">
@@ -3845,7 +3774,7 @@
                 <a:ea typeface="Calibri"/>
                 <a:cs typeface="Calibri"/>
               </a:rPr>
-              <a:t>[3] Kim et al. (2024). OpenVLA: An Open-Source Vision-Language-Action Model. arXiv:2406.09246</a:t>
+              <a:t>[3] Mahajan et al. (2020). Themis. NSDI. [4] Roughgarden (2013). Myerson’s Lemma.</a:t>
             </a:r>
           </a:p>
         </p:txBody>
@@ -4011,7 +3940,7 @@
                 <a:ea typeface="Calibri"/>
                 <a:cs typeface="Calibri"/>
               </a:rPr>
-              <a:t>HF: dku-comsci-econ206-2026 / Xinrong_Sun</a:t>
+              <a:t>HF: dku-comsci-econ206-2026 / compute-commons</a:t>
             </a:r>
           </a:p>
           <a:p xmlns:a="http://schemas.openxmlformats.org/drawingml/2006/main">
@@ -4035,7 +3964,7 @@
                 <a:ea typeface="Calibri"/>
                 <a:cs typeface="Calibri"/>
               </a:rPr>
-              <a:t>Destinations established; PS2 upload pending.</a:t>
+              <a:t>Source and release status accompany the package.</a:t>
             </a:r>
           </a:p>
         </p:txBody>
@@ -4268,7 +4197,7 @@
                 <a:ea typeface="Calibri"/>
                 <a:cs typeface="Calibri"/>
               </a:rPr>
-              <a:t>A0 landscape · 1189 × 841 mm     Synthetic evidence. Public deployment, author verification and symposium response remain to be completed.</a:t>
+              <a:t>A0 landscape · 1189 × 841 mm     Synthetic evidence. Final human review and actual symposium records must be confirmed before submission.</a:t>
             </a:r>
           </a:p>
         </p:txBody>
@@ -4307,7 +4236,7 @@
                           <a:ea typeface="Calibri"/>
                           <a:cs typeface="Calibri"/>
                         </a:rPr>
-                        <a:t>Rule</a:t>
+                        <a:t>Robot</a:t>
                       </a:r>
                     </a:p>
                   </a:txBody>
@@ -4331,7 +4260,7 @@
                           <a:ea typeface="Calibri"/>
                           <a:cs typeface="Calibri"/>
                         </a:rPr>
-                        <a:t>Worker reserve</a:t>
+                        <a:t>Queue / pose time</a:t>
                       </a:r>
                     </a:p>
                   </a:txBody>
@@ -4355,7 +4284,7 @@
                           <a:ea typeface="Calibri"/>
                           <a:cs typeface="Calibri"/>
                         </a:rPr>
-                        <a:t>Entrant credit</a:t>
+                        <a:t>Deadline</a:t>
                       </a:r>
                     </a:p>
                   </a:txBody>
@@ -4381,7 +4310,7 @@
                           <a:ea typeface="Calibri"/>
                           <a:cs typeface="Calibri"/>
                         </a:rPr>
-                        <a:t>Standard</a:t>
+                        <a:t>A</a:t>
                       </a:r>
                     </a:p>
                   </a:txBody>
@@ -4405,7 +4334,7 @@
                           <a:ea typeface="Calibri"/>
                           <a:cs typeface="Calibri"/>
                         </a:rPr>
-                        <a:t>0</a:t>
+                        <a:t>200 / 400 ms</a:t>
                       </a:r>
                     </a:p>
                   </a:txBody>
@@ -4429,7 +4358,7 @@
                           <a:ea typeface="Calibri"/>
                           <a:cs typeface="Calibri"/>
                         </a:rPr>
-                        <a:t>0</a:t>
+                        <a:t>200 ms</a:t>
                       </a:r>
                     </a:p>
                   </a:txBody>
@@ -4455,7 +4384,7 @@
                           <a:ea typeface="Calibri"/>
                           <a:cs typeface="Calibri"/>
                         </a:rPr>
-                        <a:t>Credit only</a:t>
+                        <a:t>B</a:t>
                       </a:r>
                     </a:p>
                   </a:txBody>
@@ -4479,7 +4408,7 @@
                           <a:ea typeface="Calibri"/>
                           <a:cs typeface="Calibri"/>
                         </a:rPr>
-                        <a:t>0</a:t>
+                        <a:t>400 / 200 ms</a:t>
                       </a:r>
                     </a:p>
                   </a:txBody>
@@ -4503,7 +4432,7 @@
                           <a:ea typeface="Calibri"/>
                           <a:cs typeface="Calibri"/>
                         </a:rPr>
-                        <a:t>4</a:t>
+                        <a:t>200 ms</a:t>
                       </a:r>
                     </a:p>
                   </a:txBody>
@@ -4529,7 +4458,7 @@
                           <a:ea typeface="Calibri"/>
                           <a:cs typeface="Calibri"/>
                         </a:rPr>
-                        <a:t>Reserve only</a:t>
+                        <a:t>D</a:t>
                       </a:r>
                     </a:p>
                   </a:txBody>
@@ -4553,7 +4482,7 @@
                           <a:ea typeface="Calibri"/>
                           <a:cs typeface="Calibri"/>
                         </a:rPr>
-                        <a:t>1</a:t>
+                        <a:t>400 / 400 ms</a:t>
                       </a:r>
                     </a:p>
                   </a:txBody>
@@ -4577,7 +4506,7 @@
                           <a:ea typeface="Calibri"/>
                           <a:cs typeface="Calibri"/>
                         </a:rPr>
-                        <a:t>0</a:t>
+                        <a:t>400 ms</a:t>
                       </a:r>
                     </a:p>
                   </a:txBody>
@@ -4603,7 +4532,7 @@
                           <a:ea typeface="Calibri"/>
                           <a:cs typeface="Calibri"/>
                         </a:rPr>
-                        <a:t>Both</a:t>
+                        <a:t>E</a:t>
                       </a:r>
                     </a:p>
                   </a:txBody>
@@ -4627,7 +4556,7 @@
                           <a:ea typeface="Calibri"/>
                           <a:cs typeface="Calibri"/>
                         </a:rPr>
-                        <a:t>1</a:t>
+                        <a:t>400 / 400 ms</a:t>
                       </a:r>
                     </a:p>
                   </a:txBody>
@@ -4651,7 +4580,7 @@
                           <a:ea typeface="Calibri"/>
                           <a:cs typeface="Calibri"/>
                         </a:rPr>
-                        <a:t>5</a:t>
+                        <a:t>400 ms</a:t>
                       </a:r>
                     </a:p>
                   </a:txBody>
@@ -4727,7 +4656,7 @@
                           <a:ea typeface="Calibri"/>
                           <a:cs typeface="Calibri"/>
                         </a:rPr>
-                        <a:t>Wins</a:t>
+                        <a:t>Admit</a:t>
                       </a:r>
                     </a:p>
                   </a:txBody>
@@ -4751,7 +4680,7 @@
                           <a:ea typeface="Calibri"/>
                           <a:cs typeface="Calibri"/>
                         </a:rPr>
-                        <a:t>Pays</a:t>
+                        <a:t>Pay</a:t>
                       </a:r>
                     </a:p>
                   </a:txBody>
@@ -4775,7 +4704,7 @@
                           <a:ea typeface="Calibri"/>
                           <a:cs typeface="Calibri"/>
                         </a:rPr>
-                        <a:t>Utility</a:t>
+                        <a:t>Usable</a:t>
                       </a:r>
                     </a:p>
                   </a:txBody>
@@ -4849,7 +4778,7 @@
                           <a:ea typeface="Calibri"/>
                           <a:cs typeface="Calibri"/>
                         </a:rPr>
-                        <a:t>Standard</a:t>
+                        <a:t>Generic</a:t>
                       </a:r>
                     </a:p>
                   </a:txBody>
@@ -4897,7 +4826,7 @@
                           <a:ea typeface="Calibri"/>
                           <a:cs typeface="Calibri"/>
                         </a:rPr>
-                        <a:t>6 / 6</a:t>
+                        <a:t>8 / 8</a:t>
                       </a:r>
                     </a:p>
                   </a:txBody>
@@ -4921,7 +4850,7 @@
                           <a:ea typeface="Calibri"/>
                           <a:cs typeface="Calibri"/>
                         </a:rPr>
-                        <a:t>4 / 3</a:t>
+                        <a:t>A</a:t>
                       </a:r>
                     </a:p>
                   </a:txBody>
@@ -4945,7 +4874,7 @@
                           <a:ea typeface="Calibri"/>
                           <a:cs typeface="Calibri"/>
                         </a:rPr>
-                        <a:t>19</a:t>
+                        <a:t>10</a:t>
                       </a:r>
                     </a:p>
                   </a:txBody>
@@ -4969,7 +4898,7 @@
                           <a:ea typeface="Calibri"/>
                           <a:cs typeface="Calibri"/>
                         </a:rPr>
-                        <a:t>12</a:t>
+                        <a:t>16</a:t>
                       </a:r>
                     </a:p>
                   </a:txBody>
@@ -4995,7 +4924,299 @@
                           <a:ea typeface="Calibri"/>
                           <a:cs typeface="Calibri"/>
                         </a:rPr>
-                        <a:t>Credit only</a:t>
+                        <a:t>EDF</a:t>
+                      </a:r>
+                    </a:p>
+                  </a:txBody>
+                  <a:tcPr marL="91440" marR="91440" marT="45720" marB="45720">
+                    <a:solidFill>
+                      <a:srgbClr val="EAF0F5"/>
+                    </a:solidFill>
+                  </a:tcPr>
+                </a:tc>
+                <a:tc>
+                  <a:txBody>
+                    <a:bodyPr/>
+                    <a:lstStyle/>
+                    <a:p>
+                      <a:r>
+                        <a:rPr sz="3000" b="0">
+                          <a:solidFill>
+                            <a:srgbClr val="173047"/>
+                          </a:solidFill>
+                          <a:latin typeface="Calibri"/>
+                          <a:ea typeface="Calibri"/>
+                          <a:cs typeface="Calibri"/>
+                        </a:rPr>
+                        <a:t>A, D</a:t>
+                      </a:r>
+                    </a:p>
+                  </a:txBody>
+                  <a:tcPr marL="91440" marR="91440" marT="45720" marB="45720">
+                    <a:solidFill>
+                      <a:srgbClr val="EAF0F5"/>
+                    </a:solidFill>
+                  </a:tcPr>
+                </a:tc>
+                <a:tc>
+                  <a:txBody>
+                    <a:bodyPr/>
+                    <a:lstStyle/>
+                    <a:p>
+                      <a:r>
+                        <a:rPr sz="3000" b="0">
+                          <a:solidFill>
+                            <a:srgbClr val="173047"/>
+                          </a:solidFill>
+                          <a:latin typeface="Calibri"/>
+                          <a:ea typeface="Calibri"/>
+                          <a:cs typeface="Calibri"/>
+                        </a:rPr>
+                        <a:t>0 / 0</a:t>
+                      </a:r>
+                    </a:p>
+                  </a:txBody>
+                  <a:tcPr marL="91440" marR="91440" marT="45720" marB="45720">
+                    <a:solidFill>
+                      <a:srgbClr val="EAF0F5"/>
+                    </a:solidFill>
+                  </a:tcPr>
+                </a:tc>
+                <a:tc>
+                  <a:txBody>
+                    <a:bodyPr/>
+                    <a:lstStyle/>
+                    <a:p>
+                      <a:r>
+                        <a:rPr sz="3000" b="0">
+                          <a:solidFill>
+                            <a:srgbClr val="173047"/>
+                          </a:solidFill>
+                          <a:latin typeface="Calibri"/>
+                          <a:ea typeface="Calibri"/>
+                          <a:cs typeface="Calibri"/>
+                        </a:rPr>
+                        <a:t>A, D</a:t>
+                      </a:r>
+                    </a:p>
+                  </a:txBody>
+                  <a:tcPr marL="91440" marR="91440" marT="45720" marB="45720">
+                    <a:solidFill>
+                      <a:srgbClr val="EAF0F5"/>
+                    </a:solidFill>
+                  </a:tcPr>
+                </a:tc>
+                <a:tc>
+                  <a:txBody>
+                    <a:bodyPr/>
+                    <a:lstStyle/>
+                    <a:p>
+                      <a:r>
+                        <a:rPr sz="3000" b="0">
+                          <a:solidFill>
+                            <a:srgbClr val="173047"/>
+                          </a:solidFill>
+                          <a:latin typeface="Calibri"/>
+                          <a:ea typeface="Calibri"/>
+                          <a:cs typeface="Calibri"/>
+                        </a:rPr>
+                        <a:t>18</a:t>
+                      </a:r>
+                    </a:p>
+                  </a:txBody>
+                  <a:tcPr marL="91440" marR="91440" marT="45720" marB="45720">
+                    <a:solidFill>
+                      <a:srgbClr val="EAF0F5"/>
+                    </a:solidFill>
+                  </a:tcPr>
+                </a:tc>
+                <a:tc>
+                  <a:txBody>
+                    <a:bodyPr/>
+                    <a:lstStyle/>
+                    <a:p>
+                      <a:r>
+                        <a:rPr sz="3000" b="0">
+                          <a:solidFill>
+                            <a:srgbClr val="173047"/>
+                          </a:solidFill>
+                          <a:latin typeface="Calibri"/>
+                          <a:ea typeface="Calibri"/>
+                          <a:cs typeface="Calibri"/>
+                        </a:rPr>
+                        <a:t>0</a:t>
+                      </a:r>
+                    </a:p>
+                  </a:txBody>
+                  <a:tcPr marL="91440" marR="91440" marT="45720" marB="45720">
+                    <a:solidFill>
+                      <a:srgbClr val="EAF0F5"/>
+                    </a:solidFill>
+                  </a:tcPr>
+                </a:tc>
+              </a:tr>
+              <a:tr h="838200">
+                <a:tc>
+                  <a:txBody>
+                    <a:bodyPr/>
+                    <a:lstStyle/>
+                    <a:p>
+                      <a:r>
+                        <a:rPr sz="3000" b="0">
+                          <a:solidFill>
+                            <a:srgbClr val="173047"/>
+                          </a:solidFill>
+                          <a:latin typeface="Calibri"/>
+                          <a:ea typeface="Calibri"/>
+                          <a:cs typeface="Calibri"/>
+                        </a:rPr>
+                        <a:t>Feasible</a:t>
+                      </a:r>
+                    </a:p>
+                  </a:txBody>
+                  <a:tcPr marL="91440" marR="91440" marT="45720" marB="45720">
+                    <a:solidFill>
+                      <a:srgbClr val="FFFFFF"/>
+                    </a:solidFill>
+                  </a:tcPr>
+                </a:tc>
+                <a:tc>
+                  <a:txBody>
+                    <a:bodyPr/>
+                    <a:lstStyle/>
+                    <a:p>
+                      <a:r>
+                        <a:rPr sz="3000" b="0">
+                          <a:solidFill>
+                            <a:srgbClr val="173047"/>
+                          </a:solidFill>
+                          <a:latin typeface="Calibri"/>
+                          <a:ea typeface="Calibri"/>
+                          <a:cs typeface="Calibri"/>
+                        </a:rPr>
+                        <a:t>A, D</a:t>
+                      </a:r>
+                    </a:p>
+                  </a:txBody>
+                  <a:tcPr marL="91440" marR="91440" marT="45720" marB="45720">
+                    <a:solidFill>
+                      <a:srgbClr val="FFFFFF"/>
+                    </a:solidFill>
+                  </a:tcPr>
+                </a:tc>
+                <a:tc>
+                  <a:txBody>
+                    <a:bodyPr/>
+                    <a:lstStyle/>
+                    <a:p>
+                      <a:r>
+                        <a:rPr sz="3000" b="0">
+                          <a:solidFill>
+                            <a:srgbClr val="173047"/>
+                          </a:solidFill>
+                          <a:latin typeface="Calibri"/>
+                          <a:ea typeface="Calibri"/>
+                          <a:cs typeface="Calibri"/>
+                        </a:rPr>
+                        <a:t>9 / 6</a:t>
+                      </a:r>
+                    </a:p>
+                  </a:txBody>
+                  <a:tcPr marL="91440" marR="91440" marT="45720" marB="45720">
+                    <a:solidFill>
+                      <a:srgbClr val="FFFFFF"/>
+                    </a:solidFill>
+                  </a:tcPr>
+                </a:tc>
+                <a:tc>
+                  <a:txBody>
+                    <a:bodyPr/>
+                    <a:lstStyle/>
+                    <a:p>
+                      <a:r>
+                        <a:rPr sz="3000" b="0">
+                          <a:solidFill>
+                            <a:srgbClr val="173047"/>
+                          </a:solidFill>
+                          <a:latin typeface="Calibri"/>
+                          <a:ea typeface="Calibri"/>
+                          <a:cs typeface="Calibri"/>
+                        </a:rPr>
+                        <a:t>A, D</a:t>
+                      </a:r>
+                    </a:p>
+                  </a:txBody>
+                  <a:tcPr marL="91440" marR="91440" marT="45720" marB="45720">
+                    <a:solidFill>
+                      <a:srgbClr val="FFFFFF"/>
+                    </a:solidFill>
+                  </a:tcPr>
+                </a:tc>
+                <a:tc>
+                  <a:txBody>
+                    <a:bodyPr/>
+                    <a:lstStyle/>
+                    <a:p>
+                      <a:r>
+                        <a:rPr sz="3000" b="0">
+                          <a:solidFill>
+                            <a:srgbClr val="173047"/>
+                          </a:solidFill>
+                          <a:latin typeface="Calibri"/>
+                          <a:ea typeface="Calibri"/>
+                          <a:cs typeface="Calibri"/>
+                        </a:rPr>
+                        <a:t>18</a:t>
+                      </a:r>
+                    </a:p>
+                  </a:txBody>
+                  <a:tcPr marL="91440" marR="91440" marT="45720" marB="45720">
+                    <a:solidFill>
+                      <a:srgbClr val="FFFFFF"/>
+                    </a:solidFill>
+                  </a:tcPr>
+                </a:tc>
+                <a:tc>
+                  <a:txBody>
+                    <a:bodyPr/>
+                    <a:lstStyle/>
+                    <a:p>
+                      <a:r>
+                        <a:rPr sz="3000" b="0">
+                          <a:solidFill>
+                            <a:srgbClr val="173047"/>
+                          </a:solidFill>
+                          <a:latin typeface="Calibri"/>
+                          <a:ea typeface="Calibri"/>
+                          <a:cs typeface="Calibri"/>
+                        </a:rPr>
+                        <a:t>15</a:t>
+                      </a:r>
+                    </a:p>
+                  </a:txBody>
+                  <a:tcPr marL="91440" marR="91440" marT="45720" marB="45720">
+                    <a:solidFill>
+                      <a:srgbClr val="FFFFFF"/>
+                    </a:solidFill>
+                  </a:tcPr>
+                </a:tc>
+              </a:tr>
+              <a:tr h="838200">
+                <a:tc>
+                  <a:txBody>
+                    <a:bodyPr/>
+                    <a:lstStyle/>
+                    <a:p>
+                      <a:r>
+                        <a:rPr sz="3000" b="0">
+                          <a:solidFill>
+                            <a:srgbClr val="173047"/>
+                          </a:solidFill>
+                          <a:latin typeface="Calibri"/>
+                          <a:ea typeface="Calibri"/>
+                          <a:cs typeface="Calibri"/>
+                        </a:rPr>
+                        <a:t>Credit 3</a:t>
                       </a:r>
                     </a:p>
                   </a:txBody>
@@ -5067,7 +5288,7 @@
                           <a:ea typeface="Calibri"/>
                           <a:cs typeface="Calibri"/>
                         </a:rPr>
-                        <a:t>1 / 1</a:t>
+                        <a:t>A, E</a:t>
                       </a:r>
                     </a:p>
                   </a:txBody>
@@ -5126,298 +5347,6 @@
                   </a:tcPr>
                 </a:tc>
               </a:tr>
-              <a:tr h="838200">
-                <a:tc>
-                  <a:txBody>
-                    <a:bodyPr/>
-                    <a:lstStyle/>
-                    <a:p>
-                      <a:r>
-                        <a:rPr sz="3000" b="0">
-                          <a:solidFill>
-                            <a:srgbClr val="173047"/>
-                          </a:solidFill>
-                          <a:latin typeface="Calibri"/>
-                          <a:ea typeface="Calibri"/>
-                          <a:cs typeface="Calibri"/>
-                        </a:rPr>
-                        <a:t>Reserve only</a:t>
-                      </a:r>
-                    </a:p>
-                  </a:txBody>
-                  <a:tcPr marL="91440" marR="91440" marT="45720" marB="45720">
-                    <a:solidFill>
-                      <a:srgbClr val="FFFFFF"/>
-                    </a:solidFill>
-                  </a:tcPr>
-                </a:tc>
-                <a:tc>
-                  <a:txBody>
-                    <a:bodyPr/>
-                    <a:lstStyle/>
-                    <a:p>
-                      <a:r>
-                        <a:rPr sz="3000" b="0">
-                          <a:solidFill>
-                            <a:srgbClr val="173047"/>
-                          </a:solidFill>
-                          <a:latin typeface="Calibri"/>
-                          <a:ea typeface="Calibri"/>
-                          <a:cs typeface="Calibri"/>
-                        </a:rPr>
-                        <a:t>A</a:t>
-                      </a:r>
-                    </a:p>
-                  </a:txBody>
-                  <a:tcPr marL="91440" marR="91440" marT="45720" marB="45720">
-                    <a:solidFill>
-                      <a:srgbClr val="FFFFFF"/>
-                    </a:solidFill>
-                  </a:tcPr>
-                </a:tc>
-                <a:tc>
-                  <a:txBody>
-                    <a:bodyPr/>
-                    <a:lstStyle/>
-                    <a:p>
-                      <a:r>
-                        <a:rPr sz="3000" b="0">
-                          <a:solidFill>
-                            <a:srgbClr val="173047"/>
-                          </a:solidFill>
-                          <a:latin typeface="Calibri"/>
-                          <a:ea typeface="Calibri"/>
-                          <a:cs typeface="Calibri"/>
-                        </a:rPr>
-                        <a:t>9</a:t>
-                      </a:r>
-                    </a:p>
-                  </a:txBody>
-                  <a:tcPr marL="91440" marR="91440" marT="45720" marB="45720">
-                    <a:solidFill>
-                      <a:srgbClr val="FFFFFF"/>
-                    </a:solidFill>
-                  </a:tcPr>
-                </a:tc>
-                <a:tc>
-                  <a:txBody>
-                    <a:bodyPr/>
-                    <a:lstStyle/>
-                    <a:p>
-                      <a:r>
-                        <a:rPr sz="3000" b="0">
-                          <a:solidFill>
-                            <a:srgbClr val="173047"/>
-                          </a:solidFill>
-                          <a:latin typeface="Calibri"/>
-                          <a:ea typeface="Calibri"/>
-                          <a:cs typeface="Calibri"/>
-                        </a:rPr>
-                        <a:t>1</a:t>
-                      </a:r>
-                    </a:p>
-                  </a:txBody>
-                  <a:tcPr marL="91440" marR="91440" marT="45720" marB="45720">
-                    <a:solidFill>
-                      <a:srgbClr val="FFFFFF"/>
-                    </a:solidFill>
-                  </a:tcPr>
-                </a:tc>
-                <a:tc>
-                  <a:txBody>
-                    <a:bodyPr/>
-                    <a:lstStyle/>
-                    <a:p>
-                      <a:r>
-                        <a:rPr sz="3000" b="0">
-                          <a:solidFill>
-                            <a:srgbClr val="173047"/>
-                          </a:solidFill>
-                          <a:latin typeface="Calibri"/>
-                          <a:ea typeface="Calibri"/>
-                          <a:cs typeface="Calibri"/>
-                        </a:rPr>
-                        <a:t>10</a:t>
-                      </a:r>
-                    </a:p>
-                  </a:txBody>
-                  <a:tcPr marL="91440" marR="91440" marT="45720" marB="45720">
-                    <a:solidFill>
-                      <a:srgbClr val="FFFFFF"/>
-                    </a:solidFill>
-                  </a:tcPr>
-                </a:tc>
-                <a:tc>
-                  <a:txBody>
-                    <a:bodyPr/>
-                    <a:lstStyle/>
-                    <a:p>
-                      <a:r>
-                        <a:rPr sz="3000" b="0">
-                          <a:solidFill>
-                            <a:srgbClr val="173047"/>
-                          </a:solidFill>
-                          <a:latin typeface="Calibri"/>
-                          <a:ea typeface="Calibri"/>
-                          <a:cs typeface="Calibri"/>
-                        </a:rPr>
-                        <a:t>9</a:t>
-                      </a:r>
-                    </a:p>
-                  </a:txBody>
-                  <a:tcPr marL="91440" marR="91440" marT="45720" marB="45720">
-                    <a:solidFill>
-                      <a:srgbClr val="FFFFFF"/>
-                    </a:solidFill>
-                  </a:tcPr>
-                </a:tc>
-              </a:tr>
-              <a:tr h="838200">
-                <a:tc>
-                  <a:txBody>
-                    <a:bodyPr/>
-                    <a:lstStyle/>
-                    <a:p>
-                      <a:r>
-                        <a:rPr sz="3000" b="0">
-                          <a:solidFill>
-                            <a:srgbClr val="173047"/>
-                          </a:solidFill>
-                          <a:latin typeface="Calibri"/>
-                          <a:ea typeface="Calibri"/>
-                          <a:cs typeface="Calibri"/>
-                        </a:rPr>
-                        <a:t>Both</a:t>
-                      </a:r>
-                    </a:p>
-                  </a:txBody>
-                  <a:tcPr marL="91440" marR="91440" marT="45720" marB="45720">
-                    <a:solidFill>
-                      <a:srgbClr val="EAF0F5"/>
-                    </a:solidFill>
-                  </a:tcPr>
-                </a:tc>
-                <a:tc>
-                  <a:txBody>
-                    <a:bodyPr/>
-                    <a:lstStyle/>
-                    <a:p>
-                      <a:r>
-                        <a:rPr sz="3000" b="0">
-                          <a:solidFill>
-                            <a:srgbClr val="173047"/>
-                          </a:solidFill>
-                          <a:latin typeface="Calibri"/>
-                          <a:ea typeface="Calibri"/>
-                          <a:cs typeface="Calibri"/>
-                        </a:rPr>
-                        <a:t>E</a:t>
-                      </a:r>
-                    </a:p>
-                  </a:txBody>
-                  <a:tcPr marL="91440" marR="91440" marT="45720" marB="45720">
-                    <a:solidFill>
-                      <a:srgbClr val="EAF0F5"/>
-                    </a:solidFill>
-                  </a:tcPr>
-                </a:tc>
-                <a:tc>
-                  <a:txBody>
-                    <a:bodyPr/>
-                    <a:lstStyle/>
-                    <a:p>
-                      <a:r>
-                        <a:rPr sz="3000" b="0">
-                          <a:solidFill>
-                            <a:srgbClr val="173047"/>
-                          </a:solidFill>
-                          <a:latin typeface="Calibri"/>
-                          <a:ea typeface="Calibri"/>
-                          <a:cs typeface="Calibri"/>
-                        </a:rPr>
-                        <a:t>5</a:t>
-                      </a:r>
-                    </a:p>
-                  </a:txBody>
-                  <a:tcPr marL="91440" marR="91440" marT="45720" marB="45720">
-                    <a:solidFill>
-                      <a:srgbClr val="EAF0F5"/>
-                    </a:solidFill>
-                  </a:tcPr>
-                </a:tc>
-                <a:tc>
-                  <a:txBody>
-                    <a:bodyPr/>
-                    <a:lstStyle/>
-                    <a:p>
-                      <a:r>
-                        <a:rPr sz="3000" b="0">
-                          <a:solidFill>
-                            <a:srgbClr val="173047"/>
-                          </a:solidFill>
-                          <a:latin typeface="Calibri"/>
-                          <a:ea typeface="Calibri"/>
-                          <a:cs typeface="Calibri"/>
-                        </a:rPr>
-                        <a:t>1</a:t>
-                      </a:r>
-                    </a:p>
-                  </a:txBody>
-                  <a:tcPr marL="91440" marR="91440" marT="45720" marB="45720">
-                    <a:solidFill>
-                      <a:srgbClr val="EAF0F5"/>
-                    </a:solidFill>
-                  </a:tcPr>
-                </a:tc>
-                <a:tc>
-                  <a:txBody>
-                    <a:bodyPr/>
-                    <a:lstStyle/>
-                    <a:p>
-                      <a:r>
-                        <a:rPr sz="3000" b="0">
-                          <a:solidFill>
-                            <a:srgbClr val="173047"/>
-                          </a:solidFill>
-                          <a:latin typeface="Calibri"/>
-                          <a:ea typeface="Calibri"/>
-                          <a:cs typeface="Calibri"/>
-                        </a:rPr>
-                        <a:t>6</a:t>
-                      </a:r>
-                    </a:p>
-                  </a:txBody>
-                  <a:tcPr marL="91440" marR="91440" marT="45720" marB="45720">
-                    <a:solidFill>
-                      <a:srgbClr val="EAF0F5"/>
-                    </a:solidFill>
-                  </a:tcPr>
-                </a:tc>
-                <a:tc>
-                  <a:txBody>
-                    <a:bodyPr/>
-                    <a:lstStyle/>
-                    <a:p>
-                      <a:r>
-                        <a:rPr sz="3000" b="0">
-                          <a:solidFill>
-                            <a:srgbClr val="173047"/>
-                          </a:solidFill>
-                          <a:latin typeface="Calibri"/>
-                          <a:ea typeface="Calibri"/>
-                          <a:cs typeface="Calibri"/>
-                        </a:rPr>
-                        <a:t>5</a:t>
-                      </a:r>
-                    </a:p>
-                  </a:txBody>
-                  <a:tcPr marL="91440" marR="91440" marT="45720" marB="45720">
-                    <a:solidFill>
-                      <a:srgbClr val="EAF0F5"/>
-                    </a:solidFill>
-                  </a:tcPr>
-                </a:tc>
-              </a:tr>
             </a:tbl>
           </a:graphicData>
         </a:graphic>
@@ -5433,9 +5362,9 @@
 </file>
 
 <file path=ppt/theme/theme1.xml><?xml version="1.0" encoding="utf-8"?>
-<a:theme xmlns:a="http://schemas.openxmlformats.org/drawingml/2006/main" name="ChatGPT">
+<a:theme xmlns:a="http://schemas.openxmlformats.org/drawingml/2006/main" name="Compute Commons">
   <a:themeElements>
-    <a:clrScheme name="ChatGPT">
+    <a:clrScheme name="Compute Commons">
       <a:dk1>
         <a:srgbClr val="000000"/>
       </a:dk1>
@@ -5485,7 +5414,7 @@
         <a:cs typeface="Calibri"/>
       </a:minorFont>
     </a:fontScheme>
-    <a:fmtScheme name="ChatGPT">
+    <a:fmtScheme name="Compute Commons">
       <a:fillStyleLst>
         <a:solidFill>
           <a:schemeClr val="phClr"/>

</xml_diff>